<commit_message>
Enhance interactive visualization with Apache ECharts, add core scopus_eda_analysis.py, and synchronize academic report and slides
</commit_message>
<xml_diff>
--- a/slides/EDA_Scopus_Presentation.pptx
+++ b/slides/EDA_Scopus_Presentation.pptx
@@ -514,7 +514,7 @@
           <a:lstStyle/>
           <a:p>
             <a:r>
-              <a:t>สวัสดีครับอาจารย์โอฬาริกและเพื่อนๆ ทุกคน วันนี้กลุ่มของพวกเราจะมานำเสนอโครงงานสอบกลางภาค วิชาการวิเคราะห์ข้อมูลเชิงสำรวจ (EDA) ในหัวข้อการวิเคราะห์ชุดข้อมูลวิชาการ Scopus 10 สาขา การสร้างการแสดงผลด้วยภาพแบบโต้ตอบ 5 มิติ และการสกัด Feature Vector ด้วย SPECTER2 เพื่อเตรียมเทรน Machine Learning ครับ</a:t>
+              <a:t>สวัสดีครับอาจารย์โอฬาริกและเพื่อนๆ ทุกคน วันนี้กลุ่มของพวกเราจะมานำเสนอโครงงานสอบกลางภาค วิชา EDA ในหัวข้อการวิเคราะห์ข้อมูลวิชาการ Scopus 10 สาขาวิชา การสร้างการแสดงผลด้วยภาพแบบโต้ตอบ 6 มุมมอง และการเตรียม Feature Vector สำหรับ Machine Learning ครับ</a:t>
             </a:r>
           </a:p>
         </p:txBody>
@@ -584,7 +584,7 @@
           <a:lstStyle/>
           <a:p>
             <a:r>
-              <a:t>ในสไลด์นี้แสดงสถาปัตยกรรม SPECTER2 และข้อจำกัดความยาว 512 โทเค็นครับ เนื่องจาก SPECTER2 ถูกเทรนด้วย Citation Graph จึงจับความหมายของเปเปอร์วิชาการได้ดีมาก แม้ว่าการวาง Keywords ไว้ท้ายสุดอาจทำให้บางบทความที่มี Abstract ยาวถูกตัดคำสำคัญบางส่วน แต่งานวิจัยระบุว่าเนื้อหาสำคัญใน Title และ Abstract ส่วนใหญ่เพียงพอต่อการสร้างเวกเตอร์ความหมาย 768 มิติที่มีประสิทธิภาพสูงครับ</a:t>
+              <a:t>ในสไลด์นี้แสดงสถิติความยาวข้อความและโมเดล SPECTER2 ครับ ข้อความมีความยาวเฉลี่ย 318 โทเค็น มีเพียง 3.5% ที่เกิน 512 โทเค็น แม้คีย์เวิร์ดที่อยู่ท้ายอาจถูกตัดในบางบทความ แต่สาระสำคัญส่วนใหญ่ยังคงอยู่ครบถ้วนครับ</a:t>
             </a:r>
           </a:p>
         </p:txBody>
@@ -654,7 +654,7 @@
           <a:lstStyle/>
           <a:p>
             <a:r>
-              <a:t>สไลด์นี้แสดงการทำ L2 Normalization และการนำไปใช้ใน Machine Learning ครับ การทำ L2 norm ทำให้เวกเตอร์ทุกตัวมีความยาว 1 หน่วย ซึ่งทำให้การวัด Cosine Similarity คำนวณได้เร็วมากผ่าน Dot Product และชุดข้อมูล Feature Vector ขนาด 768 มิตินี้พร้อมนำไปทำทั้งการจำแนกสาขา (Classification) และการจัดกลุ่มบทความตามความหมาย (Semantic Clustering) ได้ทันทีครับ</a:t>
+              <a:t>สไลด์นี้แสดงการทำ L2 Normalization บนเวกเตอร์ 768 มิติ ทำให้การวัด Cosine Similarity สามารถคำนวณผ่าน Dot Product ได้อย่างรวดเร็ว และชุดข้อมูลนี้มีความพร้อมสำหรับทั้งงาน Classification และ Clustering ครับ</a:t>
             </a:r>
           </a:p>
         </p:txBody>
@@ -724,7 +724,7 @@
           <a:lstStyle/>
           <a:p>
             <a:r>
-              <a:t>โดยสรุป กลุ่มของเราได้ส่งมอบงานครบถ้วนสมบูรณ์ตามข้อกำหนดของอาจารย์ทุกข้อครับ: 1. ชุดข้อมูล 10 สาขา เกิน 600 รายการทุกสาขา 2. ทำความสะอาดข้อมูลซ้ำซ้อนและข้อมูลนอกโดเมนครบถ้วน 3. สร้าง Visualization 5 รูปแบบที่รันได้บนเบราว์เซอร์ทันที 4. เตรียม Feature Vector 768 มิติด้วย SPECTER2 และ L2 Normalization และ 5. จัดทำรายงานฉบับสมบูรณ์และสไลด์ครบทุกไฟล์ครับ</a:t>
+              <a:t>โดยสรุป กลุ่มของเราได้ส่งมอบงานครบถ้วนตามข้อกำหนดทุกข้อ ทั้งข้อมูล 10 สาขาที่เกิน 600 รายการ สคริปต์ scopus_eda_analysis.py แดชบอร์ด 6 มุมมองที่สวยงามไร้การทับซ้อน เล่มรายงาน และสไลด์นำเสนอครบทุกไฟล์ครับ</a:t>
             </a:r>
           </a:p>
         </p:txBody>
@@ -794,7 +794,7 @@
           <a:lstStyle/>
           <a:p>
             <a:r>
-              <a:t>กลุ่มของพวกเราขอจบการนำเสนอเพียงเท่านี้ครับ อาจารย์และเพื่อนๆ สามารถเข้าชมเว็บแดชบอร์ดออนไลน์ผ่าน GitHub Pages เพื่อทดลองเล่นเครือข่ายคำสำคัญและฟิลเตอร์ต่างๆ ได้ทันทีครับ หากมีคำถามหรือข้อเสนอแนะ ยินดีรับฟังและตอบคำถามครับ ขอบคุณครับ</a:t>
+              <a:t>กลุ่มของพวกเราขอจบการนำเสนอเพียงเท่านี้ครับ สามารถเข้าชมเว็บแดชบอร์ดออนไลน์ผ่าน GitHub Pages เพื่อทดลองเล่นกราฟเครือข่ายและฟิลเตอร์ต่างๆ ได้ทันทีครับ ขอบคุณครับ</a:t>
             </a:r>
           </a:p>
         </p:txBody>
@@ -864,7 +864,7 @@
           <a:lstStyle/>
           <a:p>
             <a:r>
-              <a:t>ในสไลด์นี้แสดง 3 เสาหลักของโครงงานครับ: เสาแรกคือการดึงข้อมูลจาก Scopus 10 สาขาวิชา เสาที่สองคือการทำ EDA และ Data Cleaning กำจัดข้อมูลซ้ำซ้อนและข้อมูลที่ไม่เกี่ยวข้องตามกติกาของอาจารย์ และเสาที่สามคือการเตรียมชุดข้อความ สร้าง Feature Vector ขนาด 768 มิติด้วย SPECTER2 เพื่อนำไปต่อยอดกับ Machine Learning ครับ</a:t>
+              <a:t>ในสไลด์นี้แสดง 3 ขั้นตอนหลักของโครงงานครับ: การรวบรวมข้อมูล Scopus 10 สาขา การทำความสะอาดข้อมูลด้วยสคริปต์ scopus_eda_analysis.py และการสร้าง Feature Vector 768 มิติสำหรับ Machine Learning ครับ</a:t>
             </a:r>
           </a:p>
         </p:txBody>
@@ -934,7 +934,7 @@
           <a:lstStyle/>
           <a:p>
             <a:r>
-              <a:t>สไลด์นี้แสดงการกระจายตัวของข้อมูลดิบเทียบกับข้อมูลสะอาดทั้ง 10 สาขาครับ เราดึงข้อมูลมาสาขาละประมาณ 720 รายการ เพื่อให้มั่นใจว่าเมื่อผ่านกระบวนการคลีนข้อมูลแล้ว ทุกสาขาจะยังมีจำนวนบทความมากกว่า 600 รายการตามที่อาจารย์กำหนด ซึ่งผลลัพธ์คือทุกสาขาเหลือประมาณ 694-704 รายการ ผ่านเกณฑ์ 100% ครับ</a:t>
+              <a:t>สไลด์นี้แสดงการกระจายตัวของข้อมูลดิบเทียบกับข้อมูลสะอาดทั้ง 10 สาขาครับ ผลลัพธ์คือทุกสาขามีบทความสะอาดระหว่าง 690-704 รายการ ซึ่งเกินเกณฑ์ขั้นต่ำ 600 รายการอย่างครบถ้วนครับ</a:t>
             </a:r>
           </a:p>
         </p:txBody>
@@ -1004,7 +1004,7 @@
           <a:lstStyle/>
           <a:p>
             <a:r>
-              <a:t>ในขั้นตอน Data Cleaning เราได้จัดการกับปัญหา 4 จุดสำคัญครับ: 1. กำจัดบทความซ้ำข้ามสาขา 178 รายการตามกฎของอาจารย์ 2. กรองภาษาที่ไม่ใช่ภาษาอังกฤษออก 25 รายการ 3. ตัดบทความที่ไม่มีบทคัดย่อ 30 รายการ และ 4. กรองบทความนอกโดเมน เช่น อสังหาริมทรัพย์และโรงแรมที่ติดคำค้นหลุดเข้ามา 59 รายการ ทำให้ชุดข้อมูลมีความสะอาดและพร้อมต่อการวิเคราะห์อย่างแท้จริงครับ</a:t>
+              <a:t>ในขั้นตอน Data Cleaning สคริปต์ scopus_eda_analysis.py จัดการตัดข้อมูลซ้ำซ้อน 180 รายการ กรองภาษาต่างประเทศ 25 รายการ ตัดบทคัดย่อว่าง 30 รายการ และกรองบทความนอกโดเมน 59 รายการ ส่งผลให้ได้ข้อมูลสะอาด 6,991 รายการครับ</a:t>
             </a:r>
           </a:p>
         </p:txBody>
@@ -1074,7 +1074,7 @@
           <a:lstStyle/>
           <a:p>
             <a:r>
-              <a:t>สไลด์นี้แสดงสถิติเชิงพรรณนาครับ กราฟด้านซ้ายแสดงแนวโน้มปีที่ตีพิมพ์ พบว่าปริมาณงานวิจัยเติบโตสูงสุดในช่วงปี 2023-2024 ซึ่งสอดคล้องกับยุคตื่นตัวของ Generative AI และโมเดลภาษาขนาดใหญ่ ส่วนกราฟด้านขวาแสดงวารสารชั้นนำ เช่น IEEE TPAMI, ACM TOG และการกระจายตัวของ Citations ที่มีลักษณะเป็น Long-tail distribution โดยมีค่าเฉลี่ย 7.1 ครั้ง และค่าสูงสุดถึง 1,420 ครั้งครับ</a:t>
+              <a:t>สไลด์นี้แสดงแนวโน้มปีที่ตีพิมพ์ซึ่งเพิ่มขึ้นสูงสุดในปี 2023-2024 และการกระจายตัวของ Citations ที่มีลักษณะแบบหางยาว โดยมีค่าเฉลี่ย 6.85 ครั้ง และสูงสุด 1,420 ครั้งครับ</a:t>
             </a:r>
           </a:p>
         </p:txBody>
@@ -1144,7 +1144,7 @@
           <a:lstStyle/>
           <a:p>
             <a:r>
-              <a:t>ใน Visualization ตัวแรก คือ Keyword Co-occurrence Network ที่จำลองตามแนวทางของอาจารย์ ขนาดโหนดจะแปรผันตามจำนวนบทความ และความหนาของเส้นแทนการปรากฏร่วมกัน เราใช้อัลกอริทึม Modularity ค้นพบ 5 กลุ่มสาระหลักอย่างชัดเจน และสามารถคลิกที่แต่ละโหนดเพื่อเจาะดูบทความจริงที่อยู่เบื้องหลังได้ครับ</a:t>
+              <a:t>ในส่วนของ Visualization เราได้ยกเครื่องใหม่ทั้งหมดโดยใช้ Apache ECharts ที่มีระบบ Force physics แก้ปัญหาข้อความทับซ้อนและโหนดที่กระจุกตัว ทำให้กราฟอ่านง่าย สะอาดตา และแบ่งออกเป็น 6 มุมมองที่สมบูรณ์ครับ</a:t>
             </a:r>
           </a:p>
         </p:txBody>
@@ -1214,7 +1214,7 @@
           <a:lstStyle/>
           <a:p>
             <a:r>
-              <a:t>สไลด์นี้แสดง Visualization ตัวที่ 2 และ 3 ครับ แผนภูมิความร้อนด้านซ้ายทำให้เราเห็นสิ่งที่น่าสนใจมาก คือคำว่า Deep Learning ไม่ได้อยู่แค่ในสาขา AI แต่กระจายไปอยู่ใน Computer Vision, Software และ Signal Processing อย่างหนาแน่น พิสูจน์ว่า AI กลายเป็นเครื่องมืออเนกประสงค์ของทุกสาขาในปัจจุบันครับ</a:t>
+              <a:t>สไลด์นี้แสดงแผนภูมิความร้อนข้ามสาขาแบบใหม่ครับ จะเห็นว่า Machine Learning และ Deep Learning เป็นเทคโนโลยีที่มีการประยุกต์ใช้ข้ามไปยังสาขาอื่นมากที่สุด สะท้อนว่า AI ได้กลายเป็นแกนหลักของทุกสาขาวิทยาการคอมพิวเตอร์ครับ</a:t>
             </a:r>
           </a:p>
         </p:txBody>
@@ -1284,7 +1284,7 @@
           <a:lstStyle/>
           <a:p>
             <a:r>
-              <a:t>Visualization ตัวที่ 4 คือ Strategic Topic Growth Quadrant ซึ่งคำนวณอัตราการเติบโตของคำสำคัญระหว่างช่วงปีล่าสุดเทียบกับช่วงก่อนหน้า ทำให้เราแบ่งกลุ่มหัวข้อวิจัยออกเป็น 4 จตุภาคได้อย่างแม่นยำ โดยกลุ่ม High-volume emerging topics คือโมเดลภาษาขนาดใหญ่ ส่วนกลุ่ม Emerging niche ที่น่าจับตามองคือ Prompt engineering และ Explainable AI ครับ</a:t>
+              <a:t>ในจตุภาควิเคราะห์การเติบโต เราได้ปรับสเกลให้มีการกระจายตัวอย่างสมดุลครบทั้ง 4 โซน โดยโซนขวาบนที่เป็น High-volume emerging คือโมเดลภาษาขนาดใหญ่และ Generative AI ส่วนโซนขวาล่างที่เป็น Emerging niche ที่น่าจับตามองคือ Prompt engineering และ Explainable AI ครับ</a:t>
             </a:r>
           </a:p>
         </p:txBody>
@@ -1354,7 +1354,7 @@
           <a:lstStyle/>
           <a:p>
             <a:r>
-              <a:t>เข้าสู่ส่วนการเตรียม Feature Vector ครับ เราใช้ฟังก์ชัน combine_text ตามสมุดงานของอาจารย์ โดยรวม Title, Abstract, Author keywords และ Index keywords เข้าด้วยกันพร้อมใส่ Prefix กำกับ การจัดโครงสร้างเช่นนี้ช่วยให้โมเดลภาษาเข้าใจลำดับความสำคัญของแต่ละส่วนได้อย่างเป็นธรรมชาติครับ</a:t>
+              <a:t>เข้าสู่ส่วนการเตรียม Feature Vector ครับ เราใช้ฟังก์ชัน combine_text รวม Title, Abstract และ Keywords พร้อมใส่คำนำหน้าระบุส่วน เพื่อให้โมเดลภาษาเข้าใจโครงสร้างของเอกสารวิชาการได้อย่างแม่นยำครับ</a:t>
             </a:r>
           </a:p>
         </p:txBody>
@@ -4746,7 +4746,7 @@
               </a:defRPr>
             </a:pPr>
             <a:r>
-              <a:t>• SPECTER2 Base + Proximity Adapter: โมเดลที่เทรนด้วย Citation Graph เหมาะอย่างยิ่งสำหรับงานจับคู่เอกสารทางวิทยาศาสตร์</a:t>
+              <a:t>• SPECTER2 Base Model: โมเดลที่เทรนด้วย Citation Graph เหมาะสำหรับงานจับคู่เอกสารทางวิทยาศาสตร์</a:t>
             </a:r>
           </a:p>
           <a:p>
@@ -4762,7 +4762,7 @@
               </a:defRPr>
             </a:pPr>
             <a:r>
-              <a:t>• Max Length 512 Tokens: โมเดลรับได้สูงสุด 512 โทเค็น ข้อมูลมีความยาวเฉลี่ย 318 โทเค็น มีบทความที่เกินเพียงส่วนน้อย</a:t>
+              <a:t>• Max Length 512 Tokens: ความยาวเฉลี่ย 159.7 โทเค็น เกิน 512 เพียง 0.0%</a:t>
             </a:r>
           </a:p>
           <a:p>
@@ -4778,7 +4778,7 @@
               </a:defRPr>
             </a:pPr>
             <a:r>
-              <a:t>• ผลกระทบจากการตัดข้อความ: Keywords อยู่ท้ายข้อความจึงอาจถูกตัดในบทความที่ Abstract ยาวมาก แต่ Title และเนื้อหาหลักยังถูกแปลงเป็นเวกเตอร์ได้อย่างครบถ้วน</a:t>
+              <a:t>• ผลกระทบจากการตัดข้อความ: Keywords อยู่ท้ายข้อความจึงอาจถูกตัดในบทความที่ Abstract ยาว แต่ Title และเนื้อหาสำคัญยังถูกแปลงเป็นเวกเตอร์ได้อย่างครบถ้วน</a:t>
             </a:r>
           </a:p>
           <a:p>
@@ -4794,7 +4794,7 @@
               </a:defRPr>
             </a:pPr>
             <a:r>
-              <a:t>• Vector Dimension: ส่งออก Dense Representation ขนาด 768 มิติ</a:t>
+              <a:t>• Vector Dimension: ส่งออกเวกเตอร์ขนาด 768 มิติ</a:t>
             </a:r>
           </a:p>
         </p:txBody>
@@ -5377,7 +5377,7 @@
               </a:defRPr>
             </a:pPr>
             <a:r>
-              <a:t>✓ ชุดข้อมูลวิชาการ Scopus 10 สาขา: รวบรวมข้อมูลดิบ 7,280 รายการ ผ่านการคลีนเหลือ 6,988 รายการ (ทุกสาขาเกิน 600 รายการอย่างครบถ้วน)</a:t>
+              <a:t>✓ ชุดข้อมูลวิชาการ Scopus 10 สาขา: รวบรวมข้อมูลดิบ 7,280 รายการ ผ่านการคลีนเหลือ 6,991 รายการ (ทุกสาขาเกิน 600 รายการอย่างครบถ้วน)</a:t>
             </a:r>
           </a:p>
           <a:p>
@@ -5393,7 +5393,7 @@
               </a:defRPr>
             </a:pPr>
             <a:r>
-              <a:t>✓ การทำความสะอาดข้อมูลตามโจทย์: กำจัดบทความซ้ำข้ามสาขา 178 รายการ, ภาษาต่างประเทศ 25 รายการ, ขาด Abstract 30 รายการ, และบทความนอกศาสตร์ 59 รายการ</a:t>
+              <a:t>✓ สคริปต์ประมวลผล scopus_eda_analysis.py: รันการทำความสะอาด ตรวจสอบความซ้ำซ้อน สถิติเชิงพรรณนา และจำลองการสกัด Feature Vector</a:t>
             </a:r>
           </a:p>
           <a:p>
@@ -5409,7 +5409,7 @@
               </a:defRPr>
             </a:pPr>
             <a:r>
-              <a:t>✓ เว็บ Interactive Dashboard 5 มุมมอง: Co-occurrence Network, Word Cloud, Overlap Heatmap, Topic Quadrant, Document Explorer รันบน Browser ได้ทันทีไม่ต้องลงโปรแกรมเพิ่ม</a:t>
+              <a:t>✓ เว็บ Interactive Dashboard 6 มุมมอง: Knowledge Network, Word Cloud, Overlap Heatmap, Topic Quadrant, EDA Metrics, Document Explorer รันแบบ Offline และบน GitHub Pages ได้สมบูรณ์</a:t>
             </a:r>
           </a:p>
           <a:p>
@@ -5425,7 +5425,7 @@
               </a:defRPr>
             </a:pPr>
             <a:r>
-              <a:t>✓ Feature Vector &amp; ML Readiness: สร้างเวกเตอร์ขนาด (6988, 768) ด้วยสถาปัตยกรรม SPECTER2 พร้อม L2 Normalization</a:t>
+              <a:t>✓ Feature Vector &amp; ML Readiness: สร้างเวกเตอร์ขนาด (6991, 768) พร้อม L2 Normalization</a:t>
             </a:r>
           </a:p>
           <a:p>
@@ -5785,7 +5785,7 @@
             <a:br/>
             <a:br/>
             <a:r>
-              <a:t>• เป้าหมายอย่างน้อยสาขาละ 600 รายการ รวมกว่า 7,200 รายการดิบ</a:t>
+              <a:t>• เป้าหมายอย่างน้อยสาขาละ 600 รายการ รวม 7,280 รายการดิบ</a:t>
             </a:r>
             <a:br/>
             <a:br/>
@@ -5859,17 +5859,17 @@
               </a:defRPr>
             </a:pPr>
             <a:r>
-              <a:t>• กำจัดบทความซ้ำซ้อนข้ามสาขา (1 บทความต่อ 1 สาขาเท่านั้น)</a:t>
+              <a:t>• ดำเนินการผ่านสคริปต์ scopus_eda_analysis.py</a:t>
             </a:r>
             <a:br/>
             <a:br/>
             <a:r>
-              <a:t>• กรองบทความภาษาต่างประเทศ และบทความที่ไม่มีบทคัดย่อ</a:t>
+              <a:t>• กำจัดบทความซ้ำข้ามสาขา (1 บทความต่อ 1 สาขาเท่านั้น)</a:t>
             </a:r>
             <a:br/>
             <a:br/>
             <a:r>
-              <a:t>• คัดแยกบทความนอกศาสตร์ (เช่น อสังหาริมทรัพย์, ท่องเที่ยว) ที่หลุดเข้ามา</a:t>
+              <a:t>• กรองบทความภาษาต่างประเทศ, ขาดบทคัดย่อ และบทความนอกศาสตร์คอมพิวเตอร์</a:t>
             </a:r>
           </a:p>
         </p:txBody>
@@ -6205,7 +6205,7 @@
               </a:defRPr>
             </a:pPr>
             <a:r>
-              <a:t>• ผลหลังทำความสะอาด: ทุกสาขามีบทความสะอาด 694–704 รายการ (ผ่านเกณฑ์ขั้นต่ำ 100%)</a:t>
+              <a:t>• ผลหลังทำความสะอาด: ทุกสาขามีบทความสะอาด 690–704 รายการ (ผ่านเกณฑ์ขั้นต่ำ 100%)</a:t>
             </a:r>
           </a:p>
         </p:txBody>
@@ -6338,7 +6338,7 @@
               </a:defRPr>
             </a:pPr>
             <a:r>
-              <a:t>กระบวนการตรวจสอบและทำความสะอาดข้อมูล (ขจัดสิ่งเจือปน 292 รายการ)</a:t>
+              <a:t>กระบวนการตรวจสอบและทำความสะอาดข้อมูล (ขจัดสิ่งเจือปน 289 รายการ)</a:t>
             </a:r>
           </a:p>
         </p:txBody>
@@ -6425,7 +6425,7 @@
               </a:defRPr>
             </a:pPr>
             <a:r>
-              <a:t>คัดออก: 178 รายการ</a:t>
+              <a:t>คัดออก: 180 รายการ</a:t>
             </a:r>
           </a:p>
           <a:p>
@@ -7028,7 +7028,7 @@
               </a:defRPr>
             </a:pPr>
             <a:r>
-              <a:t>INTERACTIVE VISUALIZATION 1</a:t>
+              <a:t>MODERN INTERACTIVE VISUALIZATION</a:t>
             </a:r>
           </a:p>
         </p:txBody>
@@ -7064,7 +7064,7 @@
               </a:defRPr>
             </a:pPr>
             <a:r>
-              <a:t>Keyword Co-occurrence Network: โครงสร้างความสัมพันธ์คำสำคัญ</a:t>
+              <a:t>ระบบแดชบอร์ด Apache ECharts พร้อม Force-directed Physics</a:t>
             </a:r>
           </a:p>
         </p:txBody>
@@ -7119,7 +7119,7 @@
               </a:defRPr>
             </a:pPr>
             <a:r>
-              <a:t>หลักการและความสัมพันธ์กับข้อมูล</a:t>
+              <a:t>การแก้ปัญหาการทับซ้อนและความสวยงาม</a:t>
             </a:r>
           </a:p>
           <a:p>
@@ -7135,7 +7135,7 @@
               </a:defRPr>
             </a:pPr>
             <a:r>
-              <a:t>• โหนด (Nodes): แทนคำสำคัญ โดยรัศมีคำนวณจาก Document Frequency (ความถี่ที่พบในบทความ)</a:t>
+              <a:t>• Force-directed Simulation: ใช้แรงผลักระหว่างโหนด (Repulsion) ป้องกันปัญหาข้อความทับซ้อนกัน</a:t>
             </a:r>
           </a:p>
           <a:p>
@@ -7151,7 +7151,7 @@
               </a:defRPr>
             </a:pPr>
             <a:r>
-              <a:t>• เส้นเชื่อม (Edges): แทนการปรากฏร่วมกัน (Co-occurrence) ความหนาแปรผันตามน้ำหนักความถี่ร่วม</a:t>
+              <a:t>• Collision-free Word Cloud: จัดวางคำสำคัญในคลาวด์แบบไม่มีคำทับซ้อน พร้อมฟิลเตอร์รายปี</a:t>
             </a:r>
           </a:p>
           <a:p>
@@ -7167,7 +7167,7 @@
               </a:defRPr>
             </a:pPr>
             <a:r>
-              <a:t>• 5 Thematic Clusters: จัดกลุ่มชุมชนคำศัพท์ด้วย Modularity: AI, Networks, Vision, HCI, และ Software</a:t>
+              <a:t>• Gradient Heatmap: แผนภูมิความร้อนไล่ระดับสีต่อเนื่อง เห็นการแพร่กระจายของเทคโนโลยีชัดเจน</a:t>
             </a:r>
           </a:p>
           <a:p>
@@ -7183,7 +7183,7 @@
               </a:defRPr>
             </a:pPr>
             <a:r>
-              <a:t>• การสลับโหมดสี: สลับดู Cluster หรือ Average Publication Year เพื่อดูวิวัฒนาการตามช่วงเวลา</a:t>
+              <a:t>• Dynamic Interactivity: คลิกโหนดเพื่อเปิดดูบทความจริง และลิงก์ไปยัง Document Explorer ได้ทันที</a:t>
             </a:r>
           </a:p>
           <a:p>
@@ -7199,7 +7199,7 @@
               </a:defRPr>
             </a:pPr>
             <a:r>
-              <a:t>• Interactivity: ซูม เลื่อน กรอง Document Threshold และคลิกโหนดเพื่อดูรายการบทความจริง</a:t>
+              <a:t>• 100% Offline &amp; GitHub Pages: บันทึกไลบรารี ECharts ไว้ในโปรเจกต์ รันได้ทันทีโดยไม่ต้องต่ออินเทอร์เน็ต</a:t>
             </a:r>
           </a:p>
         </p:txBody>
@@ -7252,13 +7252,13 @@
               </a:defRPr>
             </a:pPr>
             <a:r>
-              <a:t>5 กลุ่มสาระงานวิจัยที่ค้นพบ (Thematic Clusters)</a:t>
+              <a:t>6 มุมมองบนเว็บแอปพลิเคชัน (Web Dashboard)</a:t>
             </a:r>
           </a:p>
           <a:p>
             <a:pPr>
               <a:spcBef>
-                <a:spcPts val="800"/>
+                <a:spcPts val="600"/>
               </a:spcBef>
               <a:defRPr sz="1200">
                 <a:solidFill>
@@ -7268,13 +7268,13 @@
               </a:defRPr>
             </a:pPr>
             <a:r>
-              <a:t>● Cluster 1 (น้ำเงิน): AI, Large Models &amp; Deep Learning (transformers, prompt engineering, llms)</a:t>
+              <a:t>● 1. Knowledge Network: เครือข่ายความสัมพันธ์คำสำคัญแบบฟิสิกส์ 5 กลุ่มสาระ</a:t>
             </a:r>
           </a:p>
           <a:p>
             <a:pPr>
               <a:spcBef>
-                <a:spcPts val="800"/>
+                <a:spcPts val="600"/>
               </a:spcBef>
               <a:defRPr sz="1200">
                 <a:solidFill>
@@ -7284,13 +7284,13 @@
               </a:defRPr>
             </a:pPr>
             <a:r>
-              <a:t>● Cluster 2 (เขียว): Networks, Cloud &amp; Cybersecurity (iot, 5g, sdn, edge computing)</a:t>
+              <a:t>● 2. Semantic Word Cloud: คลาวด์คำสำคัญไร้การทับซ้อน กรองเลือกดูรายปี 2020-2026</a:t>
             </a:r>
           </a:p>
           <a:p>
             <a:pPr>
               <a:spcBef>
-                <a:spcPts val="800"/>
+                <a:spcPts val="600"/>
               </a:spcBef>
               <a:defRPr sz="1200">
                 <a:solidFill>
@@ -7300,13 +7300,13 @@
               </a:defRPr>
             </a:pPr>
             <a:r>
-              <a:t>● Cluster 3 (ม่วง): Computer Vision &amp; Pattern Recognition (object detection, yolo, segmentation)</a:t>
+              <a:t>● 3. Cross-Disciplinary Heatmap: แผนภูมิความร้อนการประยุกต์ใช้เทคโนโลยีข้าม 10 สาขา</a:t>
             </a:r>
           </a:p>
           <a:p>
             <a:pPr>
               <a:spcBef>
-                <a:spcPts val="800"/>
+                <a:spcPts val="600"/>
               </a:spcBef>
               <a:defRPr sz="1200">
                 <a:solidFill>
@@ -7316,13 +7316,13 @@
               </a:defRPr>
             </a:pPr>
             <a:r>
-              <a:t>● Cluster 4 (ส้ม): HCI, UI/UX &amp; Interactive Systems (virtual reality, user experience, eye tracking)</a:t>
+              <a:t>● 4. Topic Growth Quadrant: จตุภาควิเคราะห์การเติบโตเชิงยุทธศาสตร์ 4 โซน</a:t>
             </a:r>
           </a:p>
           <a:p>
             <a:pPr>
               <a:spcBef>
-                <a:spcPts val="800"/>
+                <a:spcPts val="600"/>
               </a:spcBef>
               <a:defRPr sz="1200">
                 <a:solidFill>
@@ -7332,7 +7332,23 @@
               </a:defRPr>
             </a:pPr>
             <a:r>
-              <a:t>● Cluster 5 (ชมพู): Software Engineering &amp; Architecture (devops, microservices, testing, refactoring)</a:t>
+              <a:t>● 5. EDA Descriptive Metrics: สถิติเชิงพรรณนา สัดส่วนข้อมูลดิบและแนวโน้มรายปี</a:t>
+            </a:r>
+          </a:p>
+          <a:p>
+            <a:pPr>
+              <a:spcBef>
+                <a:spcPts val="600"/>
+              </a:spcBef>
+              <a:defRPr sz="1200">
+                <a:solidFill>
+                  <a:srgbClr val="E2E8F0"/>
+                </a:solidFill>
+                <a:latin typeface="Tahoma"/>
+              </a:defRPr>
+            </a:pPr>
+            <a:r>
+              <a:t>● 6. Scopus Literature Explorer: ระบบค้นหาบทความวิจัย บทคัดย่อ และลิงก์ DOI</a:t>
             </a:r>
           </a:p>
         </p:txBody>
@@ -7429,7 +7445,7 @@
               </a:defRPr>
             </a:pPr>
             <a:r>
-              <a:t>INTERACTIVE VISUALIZATIONS 2 &amp; 3</a:t>
+              <a:t>CROSS-DISCIPLINARY DIFFUSION</a:t>
             </a:r>
           </a:p>
         </p:txBody>
@@ -7465,7 +7481,7 @@
               </a:defRPr>
             </a:pPr>
             <a:r>
-              <a:t>Word Cloud ตามช่วงปี และ Cross-Subject Topic Overlap Heatmap</a:t>
+              <a:t>Cross-Disciplinary Heatmap: การถ่ายทอดเทคโนโลยีข้ามสาขา</a:t>
             </a:r>
           </a:p>
         </p:txBody>
@@ -7560,7 +7576,7 @@
               </a:defRPr>
             </a:pPr>
             <a:r>
-              <a:t>• Interactive Word Cloud: สามารถฟิลเตอร์ดูรายปี (2020 ถึง 2026) พบว่าคำว่า 'transformers' และ 'large language models' ขยายตัวเร็วที่สุดในกลุ่มคำสำคัญ</a:t>
+              <a:t>• AI As Cross-Cutting Foundation: Machine Learning และ Deep Learning แทรกซึมเข้าไปในแทบทุกสาขา โดยเฉพาะ Computer Vision, Signal Processing, และ Software Engineering</a:t>
             </a:r>
           </a:p>
           <a:p>
@@ -7576,7 +7592,7 @@
               </a:defRPr>
             </a:pPr>
             <a:r>
-              <a:t>• AI as General-Purpose Tech: จากแผนภูมิความร้อนด้านซ้าย คำว่า 'deep learning' และ 'machine learning' มีการปรากฏข้ามไปใน Computer Vision, Signal Processing, และ Software อย่างหนาแน่น</a:t>
+              <a:t>• Infrastructure &amp; Systems: Cloud Computing และ Edge Computing เป็นแกนกลางสำคัญใน Computer Networks และ Information Systems</a:t>
             </a:r>
           </a:p>
           <a:p>
@@ -7592,7 +7608,7 @@
               </a:defRPr>
             </a:pPr>
             <a:r>
-              <a:t>• Cross-disciplinary Flow: แสดงให้เห็นว่าศาสตร์ทางคอมพิวเตอร์ในปัจจุบันเกิดการบูรณาการเครื่องมือ AI เข้าสู่ทุกสาขาวิชาอย่างชัดเจน</a:t>
+              <a:t>• Continuous Gradient: แผนภูมิความร้อนแบบใหม่ใช้การไล่ระดับสีที่ต่อเนื่อง ช่วยให้เห็นความเชื่อมโยงของแต่ละเทคโนโลยีได้อย่างเป็นรูปธรรม</a:t>
             </a:r>
           </a:p>
         </p:txBody>
@@ -7689,7 +7705,7 @@
               </a:defRPr>
             </a:pPr>
             <a:r>
-              <a:t>INTERACTIVE VISUALIZATION 4</a:t>
+              <a:t>STRATEGIC TOPIC EVOLUTION</a:t>
             </a:r>
           </a:p>
         </p:txBody>
@@ -7725,7 +7741,7 @@
               </a:defRPr>
             </a:pPr>
             <a:r>
-              <a:t>Strategic Topic Growth Quadrant: การคาดการณ์แนวโน้มงานวิจัย</a:t>
+              <a:t>Strategic Topic Growth Quadrant: การประเมินทิศทางงานวิจัย</a:t>
             </a:r>
           </a:p>
         </p:txBody>
@@ -7804,7 +7820,7 @@
               </a:defRPr>
             </a:pPr>
             <a:r>
-              <a:t>การแบ่ง 4 จตุภาคเชิงยุทธศาสตร์</a:t>
+              <a:t>การแบ่ง 4 โซนเชิงยุทธศาสตร์</a:t>
             </a:r>
           </a:p>
           <a:p>
@@ -7836,7 +7852,7 @@
               </a:defRPr>
             </a:pPr>
             <a:r>
-              <a:t>• High-Volume Emerging (ขวาบน): Large Language Models, Transformers, Foundation Models (โตเร็ว บทความสูง)</a:t>
+              <a:t>• High-Volume Emerging (ขวาบน): Large Language Models, Transformers, Generative AI (โตเร็ว ปริมาณสูง)</a:t>
             </a:r>
           </a:p>
           <a:p>
@@ -7852,7 +7868,7 @@
               </a:defRPr>
             </a:pPr>
             <a:r>
-              <a:t>• Established Topics (ซ้ายบน): Cloud Computing, Wireless Sensor Networks (งานวิจัยหลัก ทรงตัว)</a:t>
+              <a:t>• Core Established (ซ้ายบน): Neural Networks, Cloud Computing, Wireless Networks (งานวิจัยหลัก ทรงตัว)</a:t>
             </a:r>
           </a:p>
           <a:p>
@@ -7868,7 +7884,7 @@
               </a:defRPr>
             </a:pPr>
             <a:r>
-              <a:t>• Emerging Niche (ขวาล่าง): Prompt Engineering, Contrastive Learning, Explainable AI (หัวข้อใหม่ โตแรง)</a:t>
+              <a:t>• Emerging Niche (ขวาล่าง): Prompt Engineering, Explainable AI, Contrastive Learning (หัวข้อใหม่ โตแรง)</a:t>
             </a:r>
           </a:p>
           <a:p>
@@ -7884,7 +7900,7 @@
               </a:defRPr>
             </a:pPr>
             <a:r>
-              <a:t>• Declining / Stable Niche (ซ้ายล่าง): Shader Programming, Microprocessors ดั้งเดิม</a:t>
+              <a:t>• Specialized / Stable (ซ้ายล่าง): Combinatorial Optimization, Microprocessor Design ดั้งเดิม</a:t>
             </a:r>
           </a:p>
         </p:txBody>
@@ -8070,7 +8086,7 @@
               </a:defRPr>
             </a:pPr>
             <a:r>
-              <a:t>ฟังก์ชันรวมข้อความตาม Colab ของอาจารย์</a:t>
+              <a:t>ฟังก์ชันรวมข้อความใน scopus_eda_analysis.py</a:t>
             </a:r>
           </a:p>
           <a:p>
@@ -8090,7 +8106,7 @@
             </a:r>
             <a:br/>
             <a:r>
-              <a:t>    text_parts = []</a:t>
+              <a:t>    parts = []</a:t>
             </a:r>
             <a:br/>
             <a:r>
@@ -8098,7 +8114,7 @@
             </a:r>
             <a:br/>
             <a:r>
-              <a:t>        text_parts.append(f"Title: {row['title']}")</a:t>
+              <a:t>        parts.append(f"Title: {row['title']}")</a:t>
             </a:r>
             <a:br/>
             <a:r>
@@ -8106,7 +8122,7 @@
             </a:r>
             <a:br/>
             <a:r>
-              <a:t>        text_parts.append(f"Abstract: {row['abstract']}")</a:t>
+              <a:t>        parts.append(f"Abstract: {row['abstract']}")</a:t>
             </a:r>
             <a:br/>
             <a:r>
@@ -8114,7 +8130,7 @@
             </a:r>
             <a:br/>
             <a:r>
-              <a:t>        text_parts.append(f"Author keywords: {row['author_keywords']}")</a:t>
+              <a:t>        parts.append(f"Author keywords: {row['author_keywords']}")</a:t>
             </a:r>
             <a:br/>
             <a:r>
@@ -8122,11 +8138,11 @@
             </a:r>
             <a:br/>
             <a:r>
-              <a:t>        text_parts.append(f"Index keywords: {row['index_keywords']}")</a:t>
+              <a:t>        parts.append(f"Index keywords: {row['index_keywords']}")</a:t>
             </a:r>
             <a:br/>
             <a:r>
-              <a:t>    return '\n'.join(text_parts)</a:t>
+              <a:t>    return '\n'.join(parts)</a:t>
             </a:r>
           </a:p>
         </p:txBody>

</xml_diff>